<commit_message>
계약기간 정정: 2024.03.31~2027.04.01 (3년 계약과 일관)
- 전 슬라이드 계약기간 표기를 올바른 날짜로 일괄 수정
- STEP 3 "계약 체결(2024.03.31 발효)"이 이미 지난 날짜를 향후 일정으로
  표시하던 오류를 "3년 차(26Y) 갱신 물량 확정"으로 수정 (기존 3년 계약의
  연차 갱신 단계임을 반영, 신규 계약 체결 아님)
- 정정 근거 회의록에 기록

Co-Authored-By: Claude Fable 5 <noreply@anthropic.com>
Claude-Session: https://claude.ai/code/session_01BnZKLwU6XbQYUWayL7mjxq
</commit_message>
<xml_diff>
--- a/docs/ea-renewal-proposal/동아그룹_Microsoft_라이선스_갱신제안서_2026.pptx
+++ b/docs/ea-renewal-proposal/동아그룹_Microsoft_라이선스_갱신제안서_2026.pptx
@@ -3376,7 +3376,7 @@
                 <a:latin typeface="맑은 고딕"/>
                 <a:ea typeface="맑은 고딕"/>
               </a:rPr>
-              <a:t>2026. 03. 31 ~ 2028. 04. 01  (3년 차 갱신)</a:t>
+              <a:t>2024. 03. 31 ~ 2027. 04. 01  (3년 차 갱신)</a:t>
             </a:r>
           </a:p>
           <a:p>
@@ -3744,7 +3744,7 @@
                 <a:latin typeface="맑은 고딕"/>
                 <a:ea typeface="맑은 고딕"/>
               </a:rPr>
-              <a:t>동아그룹 Microsoft 라이선스 갱신 제안서  |  2026.03.31 ~ 2028.04.01</a:t>
+              <a:t>동아그룹 Microsoft 라이선스 갱신 제안서  |  2024.03.31 ~ 2027.04.01</a:t>
             </a:r>
           </a:p>
         </p:txBody>
@@ -6797,7 +6797,7 @@
                 <a:latin typeface="맑은 고딕"/>
                 <a:ea typeface="맑은 고딕"/>
               </a:rPr>
-              <a:t>동아그룹 Microsoft 라이선스 갱신 제안서  |  2026.03.31 ~ 2028.04.01</a:t>
+              <a:t>동아그룹 Microsoft 라이선스 갱신 제안서  |  2024.03.31 ~ 2027.04.01</a:t>
             </a:r>
           </a:p>
         </p:txBody>
@@ -9708,7 +9708,7 @@
                 <a:latin typeface="맑은 고딕"/>
                 <a:ea typeface="맑은 고딕"/>
               </a:rPr>
-              <a:t>동아그룹 Microsoft 라이선스 갱신 제안서  |  2026.03.31 ~ 2028.04.01</a:t>
+              <a:t>동아그룹 Microsoft 라이선스 갱신 제안서  |  2024.03.31 ~ 2027.04.01</a:t>
             </a:r>
           </a:p>
         </p:txBody>
@@ -12619,7 +12619,7 @@
                 <a:latin typeface="맑은 고딕"/>
                 <a:ea typeface="맑은 고딕"/>
               </a:rPr>
-              <a:t>동아그룹 Microsoft 라이선스 갱신 제안서  |  2026.03.31 ~ 2028.04.01</a:t>
+              <a:t>동아그룹 Microsoft 라이선스 갱신 제안서  |  2024.03.31 ~ 2027.04.01</a:t>
             </a:r>
           </a:p>
         </p:txBody>
@@ -14628,7 +14628,7 @@
                 <a:latin typeface="맑은 고딕"/>
                 <a:ea typeface="맑은 고딕"/>
               </a:rPr>
-              <a:t>동아그룹 Microsoft 라이선스 갱신 제안서  |  2026.03.31 ~ 2028.04.01</a:t>
+              <a:t>동아그룹 Microsoft 라이선스 갱신 제안서  |  2024.03.31 ~ 2027.04.01</a:t>
             </a:r>
           </a:p>
         </p:txBody>
@@ -14824,7 +14824,7 @@
                           <a:latin typeface="맑은 고딕"/>
                           <a:ea typeface="맑은 고딕"/>
                         </a:rPr>
-                        <a:t>2026. 03. 31 ~ 2028. 04. 01  (3년 차 갱신)</a:t>
+                        <a:t>2024. 03. 31 ~ 2027. 04. 01  (3년 차 갱신)</a:t>
                       </a:r>
                     </a:p>
                   </a:txBody>
@@ -15710,7 +15710,7 @@
                 <a:latin typeface="맑은 고딕"/>
                 <a:ea typeface="맑은 고딕"/>
               </a:rPr>
-              <a:t>계약 체결 (2026. 03. 31 발효)</a:t>
+              <a:t>3년 차(26Y) 갱신 물량 확정</a:t>
             </a:r>
           </a:p>
         </p:txBody>
@@ -15834,7 +15834,7 @@
                 <a:latin typeface="맑은 고딕"/>
                 <a:ea typeface="맑은 고딕"/>
               </a:rPr>
-              <a:t>갱신 적용 및 연중 True-up 관리 지원</a:t>
+              <a:t>확정분 반영 및 연중 True-up 관리 지원</a:t>
             </a:r>
           </a:p>
         </p:txBody>
@@ -16528,7 +16528,7 @@
                 <a:latin typeface="맑은 고딕"/>
                 <a:ea typeface="맑은 고딕"/>
               </a:rPr>
-              <a:t>동아그룹 Microsoft 라이선스 갱신 제안서  |  2026.03.31 ~ 2028.04.01</a:t>
+              <a:t>동아그룹 Microsoft 라이선스 갱신 제안서  |  2024.03.31 ~ 2027.04.01</a:t>
             </a:r>
           </a:p>
         </p:txBody>
@@ -18282,7 +18282,7 @@
                 <a:latin typeface="맑은 고딕"/>
                 <a:ea typeface="맑은 고딕"/>
               </a:rPr>
-              <a:t>동아그룹 Microsoft 라이선스 갱신 제안서  |  2026.03.31 ~ 2028.04.01</a:t>
+              <a:t>동아그룹 Microsoft 라이선스 갱신 제안서  |  2024.03.31 ~ 2027.04.01</a:t>
             </a:r>
           </a:p>
         </p:txBody>
@@ -20197,7 +20197,7 @@
                 <a:latin typeface="맑은 고딕"/>
                 <a:ea typeface="맑은 고딕"/>
               </a:rPr>
-              <a:t>동아그룹 Microsoft 라이선스 갱신 제안서  |  2026.03.31 ~ 2028.04.01</a:t>
+              <a:t>동아그룹 Microsoft 라이선스 갱신 제안서  |  2024.03.31 ~ 2027.04.01</a:t>
             </a:r>
           </a:p>
         </p:txBody>
@@ -21488,7 +21488,7 @@
                 <a:latin typeface="맑은 고딕"/>
                 <a:ea typeface="맑은 고딕"/>
               </a:rPr>
-              <a:t>동아그룹 Microsoft 라이선스 갱신 제안서  |  2026.03.31 ~ 2028.04.01</a:t>
+              <a:t>동아그룹 Microsoft 라이선스 갱신 제안서  |  2024.03.31 ~ 2027.04.01</a:t>
             </a:r>
           </a:p>
         </p:txBody>
@@ -22930,7 +22930,7 @@
                 <a:latin typeface="맑은 고딕"/>
                 <a:ea typeface="맑은 고딕"/>
               </a:rPr>
-              <a:t>동아그룹 Microsoft 라이선스 갱신 제안서  |  2026.03.31 ~ 2028.04.01</a:t>
+              <a:t>동아그룹 Microsoft 라이선스 갱신 제안서  |  2024.03.31 ~ 2027.04.01</a:t>
             </a:r>
           </a:p>
         </p:txBody>
@@ -24760,7 +24760,7 @@
                 <a:latin typeface="맑은 고딕"/>
                 <a:ea typeface="맑은 고딕"/>
               </a:rPr>
-              <a:t>동아그룹 Microsoft 라이선스 갱신 제안서  |  2026.03.31 ~ 2028.04.01</a:t>
+              <a:t>동아그룹 Microsoft 라이선스 갱신 제안서  |  2024.03.31 ~ 2027.04.01</a:t>
             </a:r>
           </a:p>
         </p:txBody>
@@ -26493,7 +26493,7 @@
                 <a:latin typeface="맑은 고딕"/>
                 <a:ea typeface="맑은 고딕"/>
               </a:rPr>
-              <a:t>동아그룹 Microsoft 라이선스 갱신 제안서  |  2026.03.31 ~ 2028.04.01</a:t>
+              <a:t>동아그룹 Microsoft 라이선스 갱신 제안서  |  2024.03.31 ~ 2027.04.01</a:t>
             </a:r>
           </a:p>
         </p:txBody>
@@ -28703,7 +28703,7 @@
                 <a:latin typeface="맑은 고딕"/>
                 <a:ea typeface="맑은 고딕"/>
               </a:rPr>
-              <a:t>동아그룹 Microsoft 라이선스 갱신 제안서  |  2026.03.31 ~ 2028.04.01</a:t>
+              <a:t>동아그룹 Microsoft 라이선스 갱신 제안서  |  2024.03.31 ~ 2027.04.01</a:t>
             </a:r>
           </a:p>
         </p:txBody>

</xml_diff>